<commit_message>
Add speaker-script PDF (konusma metni) with per-slide Q&A; sync PPTX to deck edits
- new scripts/build_konusma_metni.py -> trexCloud_Konusma_Metni.pdf
  (per-slide narration in user's voice, filled blanks, professor Q&A,
  tricky-question drills, live-question answers, short critique)
- port deck content edits to PPTX (drop Nukon, Unsupervised AD label,
  autoencoder wording, 2-bullet conclusion); regenerate both decks
</commit_message>
<xml_diff>
--- a/trexCloud_Final_Sunum.pptx
+++ b/trexCloud_Final_Sunum.pptx
@@ -7222,35 +7222,7 @@
                 </a:solidFill>
                 <a:latin typeface="Arial"/>
               </a:rPr>
-              <a:t>Her iddia bir null model ile sınanmıştır. Olumsuz bulguları gizlemedik, çünkü güven dürüstlükten gelir.</a:t>
-            </a:r>
-          </a:p>
-          <a:p>
-            <a:pPr>
-              <a:lnSpc>
-                <a:spcPct val="110000"/>
-              </a:lnSpc>
-              <a:spcAft>
-                <a:spcPts val="1000"/>
-              </a:spcAft>
-            </a:pPr>
-            <a:r>
-              <a:rPr sz="1350" b="1">
-                <a:solidFill>
-                  <a:srgbClr val="0F7A52"/>
-                </a:solidFill>
-                <a:latin typeface="Arial"/>
-              </a:rPr>
-              <a:t>•  </a:t>
-            </a:r>
-            <a:r>
-              <a:rPr sz="1350">
-                <a:solidFill>
-                  <a:srgbClr val="16201C"/>
-                </a:solidFill>
-                <a:latin typeface="Arial"/>
-              </a:rPr>
-              <a:t>Canlı arayüz tahminden kök nedene ve What-If analizine uzanan akışı uçtan uca gösterir.</a:t>
+              <a:t>Her iddia bir null model ile sınanmıştır. Canlı arayüz tahminden kök nedene ve What-If analizine uzanan akışı uçtan uca gösterir.</a:t>
             </a:r>
           </a:p>
         </p:txBody>
@@ -7563,7 +7535,7 @@
                 </a:solidFill>
                 <a:latin typeface="Arial"/>
               </a:rPr>
-              <a:t>Tesiste 12 makine var (Fanuc, Mitsubishi, Nukon). Yaklaşık 7,4 milyon telemetri kaydı ve 153 bin MES olayı işlendi. Tüm süreler milisaniye cinsindendir.</a:t>
+              <a:t>Tesiste 12 makine var (Fanuc, Mitsubishi). Yaklaşık 7,4 milyon telemetri kaydı ve 153 bin MES olayı işlendi. Tüm süreler milisaniye cinsindendir.</a:t>
             </a:r>
           </a:p>
           <a:p>
@@ -16622,7 +16594,7 @@
                 </a:solidFill>
                 <a:latin typeface="Arial"/>
               </a:rPr>
-              <a:t>Denetimsiz AD skoru</a:t>
+              <a:t>Unsupervised AD skoru</a:t>
             </a:r>
           </a:p>
         </p:txBody>
@@ -17302,7 +17274,7 @@
                 </a:solidFill>
                 <a:latin typeface="Arial"/>
               </a:rPr>
-              <a:t>Neden HistGBDT: en yüksek PR-AUC ve ROC. Eksik değeri kendisi işler, ölçekleme istemez ve doğrusal olmayan eşikleri yakalar. CNN ile transformer yalnızca denetimsiz anomali otokodlayıcısında denendi, tahmin için avantaj sağlamadı.</a:t>
+              <a:t>Neden HistGBDT: en yüksek PR-AUC ve ROC. Eksik değeri kendisi işler, ölçekleme istemez ve doğrusal olmayan eşikleri yakalar. CNN ile transformer yalnızca denetimsiz anomali autoencoder ile denendi, tahmin için avantaj sağlamadı.</a:t>
             </a:r>
           </a:p>
         </p:txBody>

</xml_diff>